<commit_message>
Add gradient fills and a status-indicator/watermark system to design.yaml
Formally supports linear gradients (design.slide.background_gradient and
shape_styles fill), and redesigns document furniture's draft/status marker
into named placements (furniture.status.watermark/corner_tr/corner_tl/
corner_bl/corner_br) selected per build via presentation.yaml's
status_indicator field, with its text defaulting to metadata.status and
an optional TextStyle.text_transform (uppercase/lowercase/capitalize).
Adds TextStyle.opacity and Element.center to make an on-top diagonal
watermark actually legible and correctly centered.

Showcases all of this in examples/demo-deck (gradient background, faint
logo watermark, diagonal "DEMO" watermark derived from metadata.status,
plus a supplementary corner-tr render), with matching spec/CLAUDE.md
documentation and test coverage.

Co-Authored-By: Claude Sonnet 5 <noreply@anthropic.com>
</commit_message>
<xml_diff>
--- a/man/figures/demo-deck.pptx
+++ b/man/figures/demo-deck.pptx
@@ -3518,9 +3518,17 @@
   <p:cSld>
     <p:bg>
       <p:bgPr>
-        <a:solidFill>
-          <a:srgbClr val="FFFFFF"/>
-        </a:solidFill>
+        <a:gradFill rotWithShape="1">
+          <a:gsLst>
+            <a:gs pos="0">
+              <a:srgbClr val="F7FBFF"/>
+            </a:gs>
+            <a:gs pos="100000">
+              <a:srgbClr val="9ECAE1"/>
+            </a:gs>
+          </a:gsLst>
+          <a:lin scaled="0" ang="13500000"/>
+        </a:gradFill>
         <a:effectLst/>
       </p:bgPr>
     </p:bg>
@@ -3531,9 +3539,34 @@
         <p:nvPr/>
       </p:nvGrpSpPr>
       <p:grpSpPr/>
-      <p:sp>
-        <p:nvSpPr>
-          <p:cNvPr id="2" name="__furniture_branding"/>
+      <p:pic>
+        <p:nvPicPr>
+          <p:cNvPr id="2" name="__furniture_background" descr="Background image"/>
+          <p:cNvPicPr>
+            <a:picLocks noChangeAspect="1"/>
+          </p:cNvPicPr>
+          <p:nvPr/>
+        </p:nvPicPr>
+        <p:blipFill>
+          <a:blip r:embed="rId2"/>
+          <a:srcRect/>
+          <a:stretch>
+            <a:fillRect/>
+          </a:stretch>
+        </p:blipFill>
+        <p:spPr>
+          <a:xfrm>
+            <a:off x="0" y="86"/>
+            <a:ext cx="12191695" cy="6857828"/>
+          </a:xfrm>
+          <a:prstGeom prst="rect">
+            <a:avLst/>
+          </a:prstGeom>
+        </p:spPr>
+      </p:pic>
+      <p:sp>
+        <p:nvSpPr>
+          <p:cNvPr id="3" name="__furniture_branding"/>
           <p:cNvSpPr txBox="1"/>
           <p:nvPr/>
         </p:nvSpPr>
@@ -3567,7 +3600,7 @@
       </p:sp>
       <p:sp>
         <p:nvSpPr>
-          <p:cNvPr id="3" name="__furniture_page_number"/>
+          <p:cNvPr id="4" name="__furniture_page_number"/>
           <p:cNvSpPr txBox="1"/>
           <p:nvPr/>
         </p:nvSpPr>
@@ -3601,7 +3634,7 @@
       </p:sp>
       <p:sp>
         <p:nvSpPr>
-          <p:cNvPr id="4" name="deck-title"/>
+          <p:cNvPr id="5" name="deck-title"/>
           <p:cNvSpPr txBox="1"/>
           <p:nvPr/>
         </p:nvSpPr>
@@ -3635,7 +3668,7 @@
       </p:sp>
       <p:sp>
         <p:nvSpPr>
-          <p:cNvPr id="5" name="deck-subtitle"/>
+          <p:cNvPr id="6" name="deck-subtitle"/>
           <p:cNvSpPr txBox="1"/>
           <p:nvPr/>
         </p:nvSpPr>
@@ -3663,6 +3696,43 @@
                 <a:latin typeface="Arial"/>
               </a:rPr>
               <a:t>Concentration-time profiles from the built-in Theoph dataset</a:t>
+            </a:r>
+          </a:p>
+        </p:txBody>
+      </p:sp>
+      <p:sp>
+        <p:nvSpPr>
+          <p:cNvPr id="7" name="__furniture_status"/>
+          <p:cNvSpPr txBox="1"/>
+          <p:nvPr/>
+        </p:nvSpPr>
+        <p:spPr>
+          <a:xfrm rot="19800000">
+            <a:off x="1371600" y="2286000"/>
+            <a:ext cx="9448495" cy="2286000"/>
+          </a:xfrm>
+          <a:prstGeom prst="rect">
+            <a:avLst/>
+          </a:prstGeom>
+          <a:noFill/>
+        </p:spPr>
+        <p:txBody>
+          <a:bodyPr wrap="square" lIns="0" rIns="0" tIns="0" bIns="0" anchor="ctr">
+            <a:spAutoFit/>
+          </a:bodyPr>
+          <a:lstStyle/>
+          <a:p>
+            <a:pPr algn="ctr"/>
+            <a:r>
+              <a:rPr sz="9600" b="1" i="0">
+                <a:solidFill>
+                  <a:srgbClr val="2457A6">
+                    <a:alpha val="28000"/>
+                  </a:srgbClr>
+                </a:solidFill>
+                <a:latin typeface="Arial"/>
+              </a:rPr>
+              <a:t>DEMO</a:t>
             </a:r>
           </a:p>
         </p:txBody>
@@ -3680,9 +3750,17 @@
   <p:cSld>
     <p:bg>
       <p:bgPr>
-        <a:solidFill>
-          <a:srgbClr val="FFFFFF"/>
-        </a:solidFill>
+        <a:gradFill rotWithShape="1">
+          <a:gsLst>
+            <a:gs pos="0">
+              <a:srgbClr val="F7FBFF"/>
+            </a:gs>
+            <a:gs pos="100000">
+              <a:srgbClr val="9ECAE1"/>
+            </a:gs>
+          </a:gsLst>
+          <a:lin scaled="0" ang="13500000"/>
+        </a:gradFill>
         <a:effectLst/>
       </p:bgPr>
     </p:bg>
@@ -3693,9 +3771,34 @@
         <p:nvPr/>
       </p:nvGrpSpPr>
       <p:grpSpPr/>
-      <p:sp>
-        <p:nvSpPr>
-          <p:cNvPr id="2" name="__furniture_branding"/>
+      <p:pic>
+        <p:nvPicPr>
+          <p:cNvPr id="2" name="__furniture_background" descr="Background image"/>
+          <p:cNvPicPr>
+            <a:picLocks noChangeAspect="1"/>
+          </p:cNvPicPr>
+          <p:nvPr/>
+        </p:nvPicPr>
+        <p:blipFill>
+          <a:blip r:embed="rId2"/>
+          <a:srcRect/>
+          <a:stretch>
+            <a:fillRect/>
+          </a:stretch>
+        </p:blipFill>
+        <p:spPr>
+          <a:xfrm>
+            <a:off x="0" y="86"/>
+            <a:ext cx="12191695" cy="6857828"/>
+          </a:xfrm>
+          <a:prstGeom prst="rect">
+            <a:avLst/>
+          </a:prstGeom>
+        </p:spPr>
+      </p:pic>
+      <p:sp>
+        <p:nvSpPr>
+          <p:cNvPr id="3" name="__furniture_branding"/>
           <p:cNvSpPr txBox="1"/>
           <p:nvPr/>
         </p:nvSpPr>
@@ -3729,7 +3832,7 @@
       </p:sp>
       <p:sp>
         <p:nvSpPr>
-          <p:cNvPr id="3" name="__furniture_page_number"/>
+          <p:cNvPr id="4" name="__furniture_page_number"/>
           <p:cNvSpPr txBox="1"/>
           <p:nvPr/>
         </p:nvSpPr>
@@ -3763,7 +3866,7 @@
       </p:sp>
       <p:sp>
         <p:nvSpPr>
-          <p:cNvPr id="4" name="title"/>
+          <p:cNvPr id="5" name="title"/>
           <p:cNvSpPr txBox="1"/>
           <p:nvPr/>
         </p:nvSpPr>
@@ -3797,14 +3900,14 @@
       </p:sp>
       <p:pic>
         <p:nvPicPr>
-          <p:cNvPr id="5" name="figure" descr="Line plot of theophylline serum concentration over time for each of the 12 participants in the Theoph dataset, showing a rapid rise to peak concentration within the first few hours followed by a gradual decline."/>
+          <p:cNvPr id="6" name="figure" descr="Line plot of theophylline serum concentration over time for each of the 12 participants in the Theoph dataset, showing a rapid rise to peak concentration within the first few hours followed by a gradual decline."/>
           <p:cNvPicPr>
             <a:picLocks noChangeAspect="1"/>
           </p:cNvPicPr>
           <p:nvPr/>
         </p:nvPicPr>
         <p:blipFill>
-          <a:blip r:embed="rId2"/>
+          <a:blip r:embed="rId3"/>
           <a:srcRect/>
           <a:stretch>
             <a:fillRect/>
@@ -3822,7 +3925,7 @@
       </p:pic>
       <p:sp>
         <p:nvSpPr>
-          <p:cNvPr id="6" name="figure__footer"/>
+          <p:cNvPr id="7" name="figure__footer"/>
           <p:cNvSpPr txBox="1"/>
           <p:nvPr/>
         </p:nvSpPr>
@@ -3878,7 +3981,7 @@
       </p:sp>
       <p:sp>
         <p:nvSpPr>
-          <p:cNvPr id="7" name="note"/>
+          <p:cNvPr id="8" name="note"/>
           <p:cNvSpPr txBox="1"/>
           <p:nvPr/>
         </p:nvSpPr>
@@ -3946,6 +4049,43 @@
                 <a:latin typeface="Arial"/>
               </a:rPr>
               <a:t>Each line traces one participant's observed PK profile after a single oral dose; no model-based estimation was performed.</a:t>
+            </a:r>
+          </a:p>
+        </p:txBody>
+      </p:sp>
+      <p:sp>
+        <p:nvSpPr>
+          <p:cNvPr id="9" name="__furniture_status"/>
+          <p:cNvSpPr txBox="1"/>
+          <p:nvPr/>
+        </p:nvSpPr>
+        <p:spPr>
+          <a:xfrm rot="19800000">
+            <a:off x="1371600" y="2286000"/>
+            <a:ext cx="9448495" cy="2286000"/>
+          </a:xfrm>
+          <a:prstGeom prst="rect">
+            <a:avLst/>
+          </a:prstGeom>
+          <a:noFill/>
+        </p:spPr>
+        <p:txBody>
+          <a:bodyPr wrap="square" lIns="0" rIns="0" tIns="0" bIns="0" anchor="ctr">
+            <a:spAutoFit/>
+          </a:bodyPr>
+          <a:lstStyle/>
+          <a:p>
+            <a:pPr algn="ctr"/>
+            <a:r>
+              <a:rPr sz="9600" b="1" i="0">
+                <a:solidFill>
+                  <a:srgbClr val="2457A6">
+                    <a:alpha val="28000"/>
+                  </a:srgbClr>
+                </a:solidFill>
+                <a:latin typeface="Arial"/>
+              </a:rPr>
+              <a:t>DEMO</a:t>
             </a:r>
           </a:p>
         </p:txBody>
@@ -3963,9 +4103,17 @@
   <p:cSld>
     <p:bg>
       <p:bgPr>
-        <a:solidFill>
-          <a:srgbClr val="FFFFFF"/>
-        </a:solidFill>
+        <a:gradFill rotWithShape="1">
+          <a:gsLst>
+            <a:gs pos="0">
+              <a:srgbClr val="F7FBFF"/>
+            </a:gs>
+            <a:gs pos="100000">
+              <a:srgbClr val="9ECAE1"/>
+            </a:gs>
+          </a:gsLst>
+          <a:lin scaled="0" ang="13500000"/>
+        </a:gradFill>
         <a:effectLst/>
       </p:bgPr>
     </p:bg>
@@ -3976,9 +4124,34 @@
         <p:nvPr/>
       </p:nvGrpSpPr>
       <p:grpSpPr/>
-      <p:sp>
-        <p:nvSpPr>
-          <p:cNvPr id="2" name="__furniture_branding"/>
+      <p:pic>
+        <p:nvPicPr>
+          <p:cNvPr id="2" name="__furniture_background" descr="Background image"/>
+          <p:cNvPicPr>
+            <a:picLocks noChangeAspect="1"/>
+          </p:cNvPicPr>
+          <p:nvPr/>
+        </p:nvPicPr>
+        <p:blipFill>
+          <a:blip r:embed="rId2"/>
+          <a:srcRect/>
+          <a:stretch>
+            <a:fillRect/>
+          </a:stretch>
+        </p:blipFill>
+        <p:spPr>
+          <a:xfrm>
+            <a:off x="0" y="86"/>
+            <a:ext cx="12191695" cy="6857828"/>
+          </a:xfrm>
+          <a:prstGeom prst="rect">
+            <a:avLst/>
+          </a:prstGeom>
+        </p:spPr>
+      </p:pic>
+      <p:sp>
+        <p:nvSpPr>
+          <p:cNvPr id="3" name="__furniture_branding"/>
           <p:cNvSpPr txBox="1"/>
           <p:nvPr/>
         </p:nvSpPr>
@@ -4012,7 +4185,7 @@
       </p:sp>
       <p:sp>
         <p:nvSpPr>
-          <p:cNvPr id="3" name="__furniture_page_number"/>
+          <p:cNvPr id="4" name="__furniture_page_number"/>
           <p:cNvSpPr txBox="1"/>
           <p:nvPr/>
         </p:nvSpPr>
@@ -4046,7 +4219,7 @@
       </p:sp>
       <p:sp>
         <p:nvSpPr>
-          <p:cNvPr id="4" name="title"/>
+          <p:cNvPr id="5" name="title"/>
           <p:cNvSpPr txBox="1"/>
           <p:nvPr/>
         </p:nvSpPr>
@@ -4080,14 +4253,14 @@
       </p:sp>
       <p:pic>
         <p:nvPicPr>
-          <p:cNvPr id="5" name="figure" descr="First-order elimination equation: concentration at time t equals the initial concentration times e to the power of negative the elimination rate constant times t; half-life equals the natural log of 2 divided by the elimination rate constant."/>
+          <p:cNvPr id="6" name="figure" descr="First-order elimination equation: concentration at time t equals the initial concentration times e to the power of negative the elimination rate constant times t; half-life equals the natural log of 2 divided by the elimination rate constant."/>
           <p:cNvPicPr>
             <a:picLocks noChangeAspect="1"/>
           </p:cNvPicPr>
           <p:nvPr/>
         </p:nvPicPr>
         <p:blipFill>
-          <a:blip r:embed="rId2"/>
+          <a:blip r:embed="rId3"/>
           <a:srcRect/>
           <a:stretch>
             <a:fillRect/>
@@ -4105,7 +4278,7 @@
       </p:pic>
       <p:sp>
         <p:nvSpPr>
-          <p:cNvPr id="6" name="note"/>
+          <p:cNvPr id="7" name="note"/>
           <p:cNvSpPr txBox="1"/>
           <p:nvPr/>
         </p:nvSpPr>
@@ -4162,6 +4335,43 @@
                 <a:latin typeface="Arial"/>
               </a:rPr>
               <a:t>This is a simple per-participant regression for illustration, not a population PK model.</a:t>
+            </a:r>
+          </a:p>
+        </p:txBody>
+      </p:sp>
+      <p:sp>
+        <p:nvSpPr>
+          <p:cNvPr id="8" name="__furniture_status"/>
+          <p:cNvSpPr txBox="1"/>
+          <p:nvPr/>
+        </p:nvSpPr>
+        <p:spPr>
+          <a:xfrm rot="19800000">
+            <a:off x="1371600" y="2286000"/>
+            <a:ext cx="9448495" cy="2286000"/>
+          </a:xfrm>
+          <a:prstGeom prst="rect">
+            <a:avLst/>
+          </a:prstGeom>
+          <a:noFill/>
+        </p:spPr>
+        <p:txBody>
+          <a:bodyPr wrap="square" lIns="0" rIns="0" tIns="0" bIns="0" anchor="ctr">
+            <a:spAutoFit/>
+          </a:bodyPr>
+          <a:lstStyle/>
+          <a:p>
+            <a:pPr algn="ctr"/>
+            <a:r>
+              <a:rPr sz="9600" b="1" i="0">
+                <a:solidFill>
+                  <a:srgbClr val="2457A6">
+                    <a:alpha val="28000"/>
+                  </a:srgbClr>
+                </a:solidFill>
+                <a:latin typeface="Arial"/>
+              </a:rPr>
+              <a:t>DEMO</a:t>
             </a:r>
           </a:p>
         </p:txBody>
@@ -4179,9 +4389,17 @@
   <p:cSld>
     <p:bg>
       <p:bgPr>
-        <a:solidFill>
-          <a:srgbClr val="FFFFFF"/>
-        </a:solidFill>
+        <a:gradFill rotWithShape="1">
+          <a:gsLst>
+            <a:gs pos="0">
+              <a:srgbClr val="F7FBFF"/>
+            </a:gs>
+            <a:gs pos="100000">
+              <a:srgbClr val="9ECAE1"/>
+            </a:gs>
+          </a:gsLst>
+          <a:lin scaled="0" ang="13500000"/>
+        </a:gradFill>
         <a:effectLst/>
       </p:bgPr>
     </p:bg>
@@ -4192,9 +4410,34 @@
         <p:nvPr/>
       </p:nvGrpSpPr>
       <p:grpSpPr/>
-      <p:sp>
-        <p:nvSpPr>
-          <p:cNvPr id="2" name="__furniture_branding"/>
+      <p:pic>
+        <p:nvPicPr>
+          <p:cNvPr id="2" name="__furniture_background" descr="Background image"/>
+          <p:cNvPicPr>
+            <a:picLocks noChangeAspect="1"/>
+          </p:cNvPicPr>
+          <p:nvPr/>
+        </p:nvPicPr>
+        <p:blipFill>
+          <a:blip r:embed="rId2"/>
+          <a:srcRect/>
+          <a:stretch>
+            <a:fillRect/>
+          </a:stretch>
+        </p:blipFill>
+        <p:spPr>
+          <a:xfrm>
+            <a:off x="0" y="86"/>
+            <a:ext cx="12191695" cy="6857828"/>
+          </a:xfrm>
+          <a:prstGeom prst="rect">
+            <a:avLst/>
+          </a:prstGeom>
+        </p:spPr>
+      </p:pic>
+      <p:sp>
+        <p:nvSpPr>
+          <p:cNvPr id="3" name="__furniture_branding"/>
           <p:cNvSpPr txBox="1"/>
           <p:nvPr/>
         </p:nvSpPr>
@@ -4228,7 +4471,7 @@
       </p:sp>
       <p:sp>
         <p:nvSpPr>
-          <p:cNvPr id="3" name="__furniture_page_number"/>
+          <p:cNvPr id="4" name="__furniture_page_number"/>
           <p:cNvSpPr txBox="1"/>
           <p:nvPr/>
         </p:nvSpPr>
@@ -4262,7 +4505,7 @@
       </p:sp>
       <p:sp>
         <p:nvSpPr>
-          <p:cNvPr id="4" name="table-title"/>
+          <p:cNvPr id="5" name="table-title"/>
           <p:cNvSpPr txBox="1"/>
           <p:nvPr/>
         </p:nvSpPr>
@@ -4296,7 +4539,7 @@
       </p:sp>
       <p:graphicFrame>
         <p:nvGraphicFramePr>
-          <p:cNvPr id="5" name="pk-table" descr="Table of weight, dose, peak concentration, and time to peak concentration for each of the 12 participants in the Theoph dataset."/>
+          <p:cNvPr id="6" name="pk-table" descr="Table of weight, dose, peak concentration, and time to peak concentration for each of the 12 participants in the Theoph dataset."/>
           <p:cNvGraphicFramePr>
             <a:graphicFrameLocks noGrp="1"/>
           </p:cNvGraphicFramePr>
@@ -7079,6 +7322,43 @@
           </a:graphicData>
         </a:graphic>
       </p:graphicFrame>
+      <p:sp>
+        <p:nvSpPr>
+          <p:cNvPr id="7" name="__furniture_status"/>
+          <p:cNvSpPr txBox="1"/>
+          <p:nvPr/>
+        </p:nvSpPr>
+        <p:spPr>
+          <a:xfrm rot="19800000">
+            <a:off x="1371600" y="2286000"/>
+            <a:ext cx="9448495" cy="2286000"/>
+          </a:xfrm>
+          <a:prstGeom prst="rect">
+            <a:avLst/>
+          </a:prstGeom>
+          <a:noFill/>
+        </p:spPr>
+        <p:txBody>
+          <a:bodyPr wrap="square" lIns="0" rIns="0" tIns="0" bIns="0" anchor="ctr">
+            <a:spAutoFit/>
+          </a:bodyPr>
+          <a:lstStyle/>
+          <a:p>
+            <a:pPr algn="ctr"/>
+            <a:r>
+              <a:rPr sz="9600" b="1" i="0">
+                <a:solidFill>
+                  <a:srgbClr val="2457A6">
+                    <a:alpha val="28000"/>
+                  </a:srgbClr>
+                </a:solidFill>
+                <a:latin typeface="Arial"/>
+              </a:rPr>
+              <a:t>DEMO</a:t>
+            </a:r>
+          </a:p>
+        </p:txBody>
+      </p:sp>
     </p:spTree>
   </p:cSld>
   <p:clrMapOvr>
@@ -7092,9 +7372,17 @@
   <p:cSld>
     <p:bg>
       <p:bgPr>
-        <a:solidFill>
-          <a:srgbClr val="FFFFFF"/>
-        </a:solidFill>
+        <a:gradFill rotWithShape="1">
+          <a:gsLst>
+            <a:gs pos="0">
+              <a:srgbClr val="F7FBFF"/>
+            </a:gs>
+            <a:gs pos="100000">
+              <a:srgbClr val="9ECAE1"/>
+            </a:gs>
+          </a:gsLst>
+          <a:lin scaled="0" ang="13500000"/>
+        </a:gradFill>
         <a:effectLst/>
       </p:bgPr>
     </p:bg>
@@ -7105,9 +7393,34 @@
         <p:nvPr/>
       </p:nvGrpSpPr>
       <p:grpSpPr/>
-      <p:sp>
-        <p:nvSpPr>
-          <p:cNvPr id="2" name="__furniture_branding"/>
+      <p:pic>
+        <p:nvPicPr>
+          <p:cNvPr id="2" name="__furniture_background" descr="Background image"/>
+          <p:cNvPicPr>
+            <a:picLocks noChangeAspect="1"/>
+          </p:cNvPicPr>
+          <p:nvPr/>
+        </p:nvPicPr>
+        <p:blipFill>
+          <a:blip r:embed="rId2"/>
+          <a:srcRect/>
+          <a:stretch>
+            <a:fillRect/>
+          </a:stretch>
+        </p:blipFill>
+        <p:spPr>
+          <a:xfrm>
+            <a:off x="0" y="86"/>
+            <a:ext cx="12191695" cy="6857828"/>
+          </a:xfrm>
+          <a:prstGeom prst="rect">
+            <a:avLst/>
+          </a:prstGeom>
+        </p:spPr>
+      </p:pic>
+      <p:sp>
+        <p:nvSpPr>
+          <p:cNvPr id="3" name="__furniture_branding"/>
           <p:cNvSpPr txBox="1"/>
           <p:nvPr/>
         </p:nvSpPr>
@@ -7141,7 +7454,7 @@
       </p:sp>
       <p:sp>
         <p:nvSpPr>
-          <p:cNvPr id="3" name="__furniture_page_number"/>
+          <p:cNvPr id="4" name="__furniture_page_number"/>
           <p:cNvSpPr txBox="1"/>
           <p:nvPr/>
         </p:nvSpPr>
@@ -7175,7 +7488,7 @@
       </p:sp>
       <p:sp>
         <p:nvSpPr>
-          <p:cNvPr id="4" name="closing-title"/>
+          <p:cNvPr id="5" name="closing-title"/>
           <p:cNvSpPr txBox="1"/>
           <p:nvPr/>
         </p:nvSpPr>
@@ -7209,7 +7522,7 @@
       </p:sp>
       <p:sp>
         <p:nvSpPr>
-          <p:cNvPr id="5" name="closing-note"/>
+          <p:cNvPr id="6" name="closing-note"/>
           <p:cNvSpPr txBox="1"/>
           <p:nvPr/>
         </p:nvSpPr>
@@ -7261,14 +7574,14 @@
       </p:sp>
       <p:pic>
         <p:nvPicPr>
-          <p:cNvPr id="6" name="logo" descr="Organization logo"/>
+          <p:cNvPr id="7" name="logo" descr="Organization logo"/>
           <p:cNvPicPr>
             <a:picLocks noChangeAspect="1"/>
           </p:cNvPicPr>
           <p:nvPr/>
         </p:nvPicPr>
         <p:blipFill>
-          <a:blip r:embed="rId2"/>
+          <a:blip r:embed="rId3"/>
           <a:srcRect/>
           <a:stretch>
             <a:fillRect/>
@@ -7284,6 +7597,43 @@
           </a:prstGeom>
         </p:spPr>
       </p:pic>
+      <p:sp>
+        <p:nvSpPr>
+          <p:cNvPr id="8" name="__furniture_status"/>
+          <p:cNvSpPr txBox="1"/>
+          <p:nvPr/>
+        </p:nvSpPr>
+        <p:spPr>
+          <a:xfrm rot="19800000">
+            <a:off x="1371600" y="2286000"/>
+            <a:ext cx="9448495" cy="2286000"/>
+          </a:xfrm>
+          <a:prstGeom prst="rect">
+            <a:avLst/>
+          </a:prstGeom>
+          <a:noFill/>
+        </p:spPr>
+        <p:txBody>
+          <a:bodyPr wrap="square" lIns="0" rIns="0" tIns="0" bIns="0" anchor="ctr">
+            <a:spAutoFit/>
+          </a:bodyPr>
+          <a:lstStyle/>
+          <a:p>
+            <a:pPr algn="ctr"/>
+            <a:r>
+              <a:rPr sz="9600" b="1" i="0">
+                <a:solidFill>
+                  <a:srgbClr val="2457A6">
+                    <a:alpha val="28000"/>
+                  </a:srgbClr>
+                </a:solidFill>
+                <a:latin typeface="Arial"/>
+              </a:rPr>
+              <a:t>DEMO</a:t>
+            </a:r>
+          </a:p>
+        </p:txBody>
+      </p:sp>
     </p:spTree>
   </p:cSld>
   <p:clrMapOvr>

</xml_diff>

<commit_message>
Add color-token derivation and document the YAML config schema
design.yaml colors: entries can now be derived from another token via
an HSL-space transform (lighten/darken/saturate/desaturate/mix)
instead of always being a hand-picked literal, resolved once in
cli._load_project via stdlib colorsys so every existing consumer
works unchanged. Add a "YAML Configuration Reference" vignette
covering the full design/layouts/presentation schema, and give every
exported R function a runnable @examples block, since investigating
the color feature surfaced how thin the docs were in both places.

demo-deck's table banding now uses a derived primary-tint token
instead of a hand-picked literal, so its screenshots/downloadable
.pptx are regenerated to match.

Closes #11
Closes #15
Closes #16

Co-Authored-By: Claude Sonnet 5 <noreply@anthropic.com>
</commit_message>
<xml_diff>
--- a/man/figures/demo-deck.pptx
+++ b/man/figures/demo-deck.pptx
@@ -5025,7 +5025,7 @@
                       </a:solidFill>
                     </a:lnB>
                     <a:solidFill>
-                      <a:srgbClr val="EEF3FB"/>
+                      <a:srgbClr val="E8EFFA"/>
                     </a:solidFill>
                   </a:tcPr>
                 </a:tc>
@@ -5067,7 +5067,7 @@
                       </a:solidFill>
                     </a:lnB>
                     <a:solidFill>
-                      <a:srgbClr val="EEF3FB"/>
+                      <a:srgbClr val="E8EFFA"/>
                     </a:solidFill>
                   </a:tcPr>
                 </a:tc>
@@ -5109,7 +5109,7 @@
                       </a:solidFill>
                     </a:lnB>
                     <a:solidFill>
-                      <a:srgbClr val="EEF3FB"/>
+                      <a:srgbClr val="E8EFFA"/>
                     </a:solidFill>
                   </a:tcPr>
                 </a:tc>
@@ -5151,7 +5151,7 @@
                       </a:solidFill>
                     </a:lnB>
                     <a:solidFill>
-                      <a:srgbClr val="EEF3FB"/>
+                      <a:srgbClr val="E8EFFA"/>
                     </a:solidFill>
                   </a:tcPr>
                 </a:tc>
@@ -5193,7 +5193,7 @@
                       </a:solidFill>
                     </a:lnB>
                     <a:solidFill>
-                      <a:srgbClr val="EEF3FB"/>
+                      <a:srgbClr val="E8EFFA"/>
                     </a:solidFill>
                   </a:tcPr>
                 </a:tc>
@@ -5449,7 +5449,7 @@
                       </a:solidFill>
                     </a:lnB>
                     <a:solidFill>
-                      <a:srgbClr val="EEF3FB"/>
+                      <a:srgbClr val="E8EFFA"/>
                     </a:solidFill>
                   </a:tcPr>
                 </a:tc>
@@ -5491,7 +5491,7 @@
                       </a:solidFill>
                     </a:lnB>
                     <a:solidFill>
-                      <a:srgbClr val="EEF3FB"/>
+                      <a:srgbClr val="E8EFFA"/>
                     </a:solidFill>
                   </a:tcPr>
                 </a:tc>
@@ -5533,7 +5533,7 @@
                       </a:solidFill>
                     </a:lnB>
                     <a:solidFill>
-                      <a:srgbClr val="EEF3FB"/>
+                      <a:srgbClr val="E8EFFA"/>
                     </a:solidFill>
                   </a:tcPr>
                 </a:tc>
@@ -5575,7 +5575,7 @@
                       </a:solidFill>
                     </a:lnB>
                     <a:solidFill>
-                      <a:srgbClr val="EEF3FB"/>
+                      <a:srgbClr val="E8EFFA"/>
                     </a:solidFill>
                   </a:tcPr>
                 </a:tc>
@@ -5617,7 +5617,7 @@
                       </a:solidFill>
                     </a:lnB>
                     <a:solidFill>
-                      <a:srgbClr val="EEF3FB"/>
+                      <a:srgbClr val="E8EFFA"/>
                     </a:solidFill>
                   </a:tcPr>
                 </a:tc>
@@ -5873,7 +5873,7 @@
                       </a:solidFill>
                     </a:lnB>
                     <a:solidFill>
-                      <a:srgbClr val="EEF3FB"/>
+                      <a:srgbClr val="E8EFFA"/>
                     </a:solidFill>
                   </a:tcPr>
                 </a:tc>
@@ -5915,7 +5915,7 @@
                       </a:solidFill>
                     </a:lnB>
                     <a:solidFill>
-                      <a:srgbClr val="EEF3FB"/>
+                      <a:srgbClr val="E8EFFA"/>
                     </a:solidFill>
                   </a:tcPr>
                 </a:tc>
@@ -5957,7 +5957,7 @@
                       </a:solidFill>
                     </a:lnB>
                     <a:solidFill>
-                      <a:srgbClr val="EEF3FB"/>
+                      <a:srgbClr val="E8EFFA"/>
                     </a:solidFill>
                   </a:tcPr>
                 </a:tc>
@@ -5999,7 +5999,7 @@
                       </a:solidFill>
                     </a:lnB>
                     <a:solidFill>
-                      <a:srgbClr val="EEF3FB"/>
+                      <a:srgbClr val="E8EFFA"/>
                     </a:solidFill>
                   </a:tcPr>
                 </a:tc>
@@ -6041,7 +6041,7 @@
                       </a:solidFill>
                     </a:lnB>
                     <a:solidFill>
-                      <a:srgbClr val="EEF3FB"/>
+                      <a:srgbClr val="E8EFFA"/>
                     </a:solidFill>
                   </a:tcPr>
                 </a:tc>
@@ -6297,7 +6297,7 @@
                       </a:solidFill>
                     </a:lnB>
                     <a:solidFill>
-                      <a:srgbClr val="EEF3FB"/>
+                      <a:srgbClr val="E8EFFA"/>
                     </a:solidFill>
                   </a:tcPr>
                 </a:tc>
@@ -6339,7 +6339,7 @@
                       </a:solidFill>
                     </a:lnB>
                     <a:solidFill>
-                      <a:srgbClr val="EEF3FB"/>
+                      <a:srgbClr val="E8EFFA"/>
                     </a:solidFill>
                   </a:tcPr>
                 </a:tc>
@@ -6381,7 +6381,7 @@
                       </a:solidFill>
                     </a:lnB>
                     <a:solidFill>
-                      <a:srgbClr val="EEF3FB"/>
+                      <a:srgbClr val="E8EFFA"/>
                     </a:solidFill>
                   </a:tcPr>
                 </a:tc>
@@ -6423,7 +6423,7 @@
                       </a:solidFill>
                     </a:lnB>
                     <a:solidFill>
-                      <a:srgbClr val="EEF3FB"/>
+                      <a:srgbClr val="E8EFFA"/>
                     </a:solidFill>
                   </a:tcPr>
                 </a:tc>
@@ -6465,7 +6465,7 @@
                       </a:solidFill>
                     </a:lnB>
                     <a:solidFill>
-                      <a:srgbClr val="EEF3FB"/>
+                      <a:srgbClr val="E8EFFA"/>
                     </a:solidFill>
                   </a:tcPr>
                 </a:tc>
@@ -6721,7 +6721,7 @@
                       </a:solidFill>
                     </a:lnB>
                     <a:solidFill>
-                      <a:srgbClr val="EEF3FB"/>
+                      <a:srgbClr val="E8EFFA"/>
                     </a:solidFill>
                   </a:tcPr>
                 </a:tc>
@@ -6763,7 +6763,7 @@
                       </a:solidFill>
                     </a:lnB>
                     <a:solidFill>
-                      <a:srgbClr val="EEF3FB"/>
+                      <a:srgbClr val="E8EFFA"/>
                     </a:solidFill>
                   </a:tcPr>
                 </a:tc>
@@ -6805,7 +6805,7 @@
                       </a:solidFill>
                     </a:lnB>
                     <a:solidFill>
-                      <a:srgbClr val="EEF3FB"/>
+                      <a:srgbClr val="E8EFFA"/>
                     </a:solidFill>
                   </a:tcPr>
                 </a:tc>
@@ -6847,7 +6847,7 @@
                       </a:solidFill>
                     </a:lnB>
                     <a:solidFill>
-                      <a:srgbClr val="EEF3FB"/>
+                      <a:srgbClr val="E8EFFA"/>
                     </a:solidFill>
                   </a:tcPr>
                 </a:tc>
@@ -6889,7 +6889,7 @@
                       </a:solidFill>
                     </a:lnB>
                     <a:solidFill>
-                      <a:srgbClr val="EEF3FB"/>
+                      <a:srgbClr val="E8EFFA"/>
                     </a:solidFill>
                   </a:tcPr>
                 </a:tc>
@@ -7145,7 +7145,7 @@
                       </a:solidFill>
                     </a:lnB>
                     <a:solidFill>
-                      <a:srgbClr val="EEF3FB"/>
+                      <a:srgbClr val="E8EFFA"/>
                     </a:solidFill>
                   </a:tcPr>
                 </a:tc>
@@ -7187,7 +7187,7 @@
                       </a:solidFill>
                     </a:lnB>
                     <a:solidFill>
-                      <a:srgbClr val="EEF3FB"/>
+                      <a:srgbClr val="E8EFFA"/>
                     </a:solidFill>
                   </a:tcPr>
                 </a:tc>
@@ -7229,7 +7229,7 @@
                       </a:solidFill>
                     </a:lnB>
                     <a:solidFill>
-                      <a:srgbClr val="EEF3FB"/>
+                      <a:srgbClr val="E8EFFA"/>
                     </a:solidFill>
                   </a:tcPr>
                 </a:tc>
@@ -7271,7 +7271,7 @@
                       </a:solidFill>
                     </a:lnB>
                     <a:solidFill>
-                      <a:srgbClr val="EEF3FB"/>
+                      <a:srgbClr val="E8EFFA"/>
                     </a:solidFill>
                   </a:tcPr>
                 </a:tc>
@@ -7313,7 +7313,7 @@
                       </a:solidFill>
                     </a:lnB>
                     <a:solidFill>
-                      <a:srgbClr val="EEF3FB"/>
+                      <a:srgbClr val="E8EFFA"/>
                     </a:solidFill>
                   </a:tcPr>
                 </a:tc>

</xml_diff>